<commit_message>
fix s.e. estimation errors, add improved diagnostics
</commit_message>
<xml_diff>
--- a/04_presentations/01_powerpoint/06_Jeroen.pptx
+++ b/04_presentations/01_powerpoint/06_Jeroen.pptx
@@ -7,6 +7,7 @@
   <p:sldIdLst>
     <p:sldId id="256" r:id="rId2"/>
     <p:sldId id="257" r:id="rId3"/>
+    <p:sldId id="258" r:id="rId4"/>
   </p:sldIdLst>
   <p:sldSz cx="12192000" cy="6858000"/>
   <p:notesSz cx="6858000" cy="9144000"/>
@@ -105,6 +106,11 @@
       </a:defRPr>
     </a:lvl9pPr>
   </p:defaultTextStyle>
+  <p:extLst>
+    <p:ext uri="{EFAFB233-063F-42B5-8137-9DF3F51BA10A}">
+      <p15:sldGuideLst xmlns:p15="http://schemas.microsoft.com/office/powerpoint/2012/main"/>
+    </p:ext>
+  </p:extLst>
 </p:presentation>
 </file>
 
@@ -255,7 +261,7 @@
           <a:p>
             <a:fld id="{2642D604-5A06-4222-909A-95995939C497}" type="datetimeFigureOut">
               <a:rPr lang="en-US" smtClean="0"/>
-              <a:t>3/27/2026</a:t>
+              <a:t>3/31/2026</a:t>
             </a:fld>
             <a:endParaRPr lang="en-US"/>
           </a:p>
@@ -453,7 +459,7 @@
           <a:p>
             <a:fld id="{2642D604-5A06-4222-909A-95995939C497}" type="datetimeFigureOut">
               <a:rPr lang="en-US" smtClean="0"/>
-              <a:t>3/27/2026</a:t>
+              <a:t>3/31/2026</a:t>
             </a:fld>
             <a:endParaRPr lang="en-US"/>
           </a:p>
@@ -661,7 +667,7 @@
           <a:p>
             <a:fld id="{2642D604-5A06-4222-909A-95995939C497}" type="datetimeFigureOut">
               <a:rPr lang="en-US" smtClean="0"/>
-              <a:t>3/27/2026</a:t>
+              <a:t>3/31/2026</a:t>
             </a:fld>
             <a:endParaRPr lang="en-US"/>
           </a:p>
@@ -859,7 +865,7 @@
           <a:p>
             <a:fld id="{2642D604-5A06-4222-909A-95995939C497}" type="datetimeFigureOut">
               <a:rPr lang="en-US" smtClean="0"/>
-              <a:t>3/27/2026</a:t>
+              <a:t>3/31/2026</a:t>
             </a:fld>
             <a:endParaRPr lang="en-US"/>
           </a:p>
@@ -1134,7 +1140,7 @@
           <a:p>
             <a:fld id="{2642D604-5A06-4222-909A-95995939C497}" type="datetimeFigureOut">
               <a:rPr lang="en-US" smtClean="0"/>
-              <a:t>3/27/2026</a:t>
+              <a:t>3/31/2026</a:t>
             </a:fld>
             <a:endParaRPr lang="en-US"/>
           </a:p>
@@ -1399,7 +1405,7 @@
           <a:p>
             <a:fld id="{2642D604-5A06-4222-909A-95995939C497}" type="datetimeFigureOut">
               <a:rPr lang="en-US" smtClean="0"/>
-              <a:t>3/27/2026</a:t>
+              <a:t>3/31/2026</a:t>
             </a:fld>
             <a:endParaRPr lang="en-US"/>
           </a:p>
@@ -1811,7 +1817,7 @@
           <a:p>
             <a:fld id="{2642D604-5A06-4222-909A-95995939C497}" type="datetimeFigureOut">
               <a:rPr lang="en-US" smtClean="0"/>
-              <a:t>3/27/2026</a:t>
+              <a:t>3/31/2026</a:t>
             </a:fld>
             <a:endParaRPr lang="en-US"/>
           </a:p>
@@ -1952,7 +1958,7 @@
           <a:p>
             <a:fld id="{2642D604-5A06-4222-909A-95995939C497}" type="datetimeFigureOut">
               <a:rPr lang="en-US" smtClean="0"/>
-              <a:t>3/27/2026</a:t>
+              <a:t>3/31/2026</a:t>
             </a:fld>
             <a:endParaRPr lang="en-US"/>
           </a:p>
@@ -2065,7 +2071,7 @@
           <a:p>
             <a:fld id="{2642D604-5A06-4222-909A-95995939C497}" type="datetimeFigureOut">
               <a:rPr lang="en-US" smtClean="0"/>
-              <a:t>3/27/2026</a:t>
+              <a:t>3/31/2026</a:t>
             </a:fld>
             <a:endParaRPr lang="en-US"/>
           </a:p>
@@ -2376,7 +2382,7 @@
           <a:p>
             <a:fld id="{2642D604-5A06-4222-909A-95995939C497}" type="datetimeFigureOut">
               <a:rPr lang="en-US" smtClean="0"/>
-              <a:t>3/27/2026</a:t>
+              <a:t>3/31/2026</a:t>
             </a:fld>
             <a:endParaRPr lang="en-US"/>
           </a:p>
@@ -2664,7 +2670,7 @@
           <a:p>
             <a:fld id="{2642D604-5A06-4222-909A-95995939C497}" type="datetimeFigureOut">
               <a:rPr lang="en-US" smtClean="0"/>
-              <a:t>3/27/2026</a:t>
+              <a:t>3/31/2026</a:t>
             </a:fld>
             <a:endParaRPr lang="en-US"/>
           </a:p>
@@ -2905,7 +2911,7 @@
           <a:p>
             <a:fld id="{2642D604-5A06-4222-909A-95995939C497}" type="datetimeFigureOut">
               <a:rPr lang="en-US" smtClean="0"/>
-              <a:t>3/27/2026</a:t>
+              <a:t>3/31/2026</a:t>
             </a:fld>
             <a:endParaRPr lang="en-US"/>
           </a:p>
@@ -3499,6 +3505,101 @@
     <p:extLst>
       <p:ext uri="{BB962C8B-B14F-4D97-AF65-F5344CB8AC3E}">
         <p14:creationId xmlns:p14="http://schemas.microsoft.com/office/powerpoint/2010/main" val="2115130472"/>
+      </p:ext>
+    </p:extLst>
+  </p:cSld>
+  <p:clrMapOvr>
+    <a:masterClrMapping/>
+  </p:clrMapOvr>
+</p:sld>
+</file>
+
+<file path=ppt/slides/slide3.xml><?xml version="1.0" encoding="utf-8"?>
+<p:sld xmlns:a="http://schemas.openxmlformats.org/drawingml/2006/main" xmlns:r="http://schemas.openxmlformats.org/officeDocument/2006/relationships" xmlns:p="http://schemas.openxmlformats.org/presentationml/2006/main">
+  <p:cSld>
+    <p:spTree>
+      <p:nvGrpSpPr>
+        <p:cNvPr id="1" name=""/>
+        <p:cNvGrpSpPr/>
+        <p:nvPr/>
+      </p:nvGrpSpPr>
+      <p:grpSpPr>
+        <a:xfrm>
+          <a:off x="0" y="0"/>
+          <a:ext cx="0" cy="0"/>
+          <a:chOff x="0" y="0"/>
+          <a:chExt cx="0" cy="0"/>
+        </a:xfrm>
+      </p:grpSpPr>
+      <p:sp>
+        <p:nvSpPr>
+          <p:cNvPr id="2" name="Title 1">
+            <a:extLst>
+              <a:ext uri="{FF2B5EF4-FFF2-40B4-BE49-F238E27FC236}">
+                <a16:creationId xmlns:a16="http://schemas.microsoft.com/office/drawing/2014/main" id="{B9D99121-B034-B613-40B0-AE64936E0576}"/>
+              </a:ext>
+            </a:extLst>
+          </p:cNvPr>
+          <p:cNvSpPr>
+            <a:spLocks noGrp="1"/>
+          </p:cNvSpPr>
+          <p:nvPr>
+            <p:ph type="title"/>
+          </p:nvPr>
+        </p:nvSpPr>
+        <p:spPr/>
+        <p:txBody>
+          <a:bodyPr/>
+          <a:lstStyle/>
+          <a:p>
+            <a:r>
+              <a:rPr lang="en-US" dirty="0"/>
+              <a:t>Effect </a:t>
+            </a:r>
+            <a:r>
+              <a:rPr lang="en-US"/>
+              <a:t>of burn-in</a:t>
+            </a:r>
+            <a:endParaRPr lang="en-US" dirty="0"/>
+          </a:p>
+        </p:txBody>
+      </p:sp>
+      <p:pic>
+        <p:nvPicPr>
+          <p:cNvPr id="5" name="Content Placeholder 4">
+            <a:extLst>
+              <a:ext uri="{FF2B5EF4-FFF2-40B4-BE49-F238E27FC236}">
+                <a16:creationId xmlns:a16="http://schemas.microsoft.com/office/drawing/2014/main" id="{5D3B0A32-4B26-15F2-D960-605C2E07C962}"/>
+              </a:ext>
+            </a:extLst>
+          </p:cNvPr>
+          <p:cNvPicPr>
+            <a:picLocks noGrp="1" noChangeAspect="1"/>
+          </p:cNvPicPr>
+          <p:nvPr>
+            <p:ph idx="1"/>
+          </p:nvPr>
+        </p:nvPicPr>
+        <p:blipFill>
+          <a:blip r:embed="rId2"/>
+          <a:stretch>
+            <a:fillRect/>
+          </a:stretch>
+        </p:blipFill>
+        <p:spPr>
+          <a:xfrm>
+            <a:off x="838200" y="1690688"/>
+            <a:ext cx="7823138" cy="4969994"/>
+          </a:xfrm>
+          <a:prstGeom prst="rect">
+            <a:avLst/>
+          </a:prstGeom>
+        </p:spPr>
+      </p:pic>
+    </p:spTree>
+    <p:extLst>
+      <p:ext uri="{BB962C8B-B14F-4D97-AF65-F5344CB8AC3E}">
+        <p14:creationId xmlns:p14="http://schemas.microsoft.com/office/powerpoint/2010/main" val="3068104984"/>
       </p:ext>
     </p:extLst>
   </p:cSld>

</xml_diff>

<commit_message>
add new sim engine
</commit_message>
<xml_diff>
--- a/04_presentations/01_powerpoint/06_Jeroen.pptx
+++ b/04_presentations/01_powerpoint/06_Jeroen.pptx
@@ -8,6 +8,7 @@
     <p:sldId id="256" r:id="rId2"/>
     <p:sldId id="257" r:id="rId3"/>
     <p:sldId id="258" r:id="rId4"/>
+    <p:sldId id="259" r:id="rId5"/>
   </p:sldIdLst>
   <p:sldSz cx="12192000" cy="6858000"/>
   <p:notesSz cx="6858000" cy="9144000"/>
@@ -261,7 +262,7 @@
           <a:p>
             <a:fld id="{2642D604-5A06-4222-909A-95995939C497}" type="datetimeFigureOut">
               <a:rPr lang="en-US" smtClean="0"/>
-              <a:t>3/31/2026</a:t>
+              <a:t>4/2/2026</a:t>
             </a:fld>
             <a:endParaRPr lang="en-US"/>
           </a:p>
@@ -459,7 +460,7 @@
           <a:p>
             <a:fld id="{2642D604-5A06-4222-909A-95995939C497}" type="datetimeFigureOut">
               <a:rPr lang="en-US" smtClean="0"/>
-              <a:t>3/31/2026</a:t>
+              <a:t>4/2/2026</a:t>
             </a:fld>
             <a:endParaRPr lang="en-US"/>
           </a:p>
@@ -667,7 +668,7 @@
           <a:p>
             <a:fld id="{2642D604-5A06-4222-909A-95995939C497}" type="datetimeFigureOut">
               <a:rPr lang="en-US" smtClean="0"/>
-              <a:t>3/31/2026</a:t>
+              <a:t>4/2/2026</a:t>
             </a:fld>
             <a:endParaRPr lang="en-US"/>
           </a:p>
@@ -865,7 +866,7 @@
           <a:p>
             <a:fld id="{2642D604-5A06-4222-909A-95995939C497}" type="datetimeFigureOut">
               <a:rPr lang="en-US" smtClean="0"/>
-              <a:t>3/31/2026</a:t>
+              <a:t>4/2/2026</a:t>
             </a:fld>
             <a:endParaRPr lang="en-US"/>
           </a:p>
@@ -1140,7 +1141,7 @@
           <a:p>
             <a:fld id="{2642D604-5A06-4222-909A-95995939C497}" type="datetimeFigureOut">
               <a:rPr lang="en-US" smtClean="0"/>
-              <a:t>3/31/2026</a:t>
+              <a:t>4/2/2026</a:t>
             </a:fld>
             <a:endParaRPr lang="en-US"/>
           </a:p>
@@ -1405,7 +1406,7 @@
           <a:p>
             <a:fld id="{2642D604-5A06-4222-909A-95995939C497}" type="datetimeFigureOut">
               <a:rPr lang="en-US" smtClean="0"/>
-              <a:t>3/31/2026</a:t>
+              <a:t>4/2/2026</a:t>
             </a:fld>
             <a:endParaRPr lang="en-US"/>
           </a:p>
@@ -1817,7 +1818,7 @@
           <a:p>
             <a:fld id="{2642D604-5A06-4222-909A-95995939C497}" type="datetimeFigureOut">
               <a:rPr lang="en-US" smtClean="0"/>
-              <a:t>3/31/2026</a:t>
+              <a:t>4/2/2026</a:t>
             </a:fld>
             <a:endParaRPr lang="en-US"/>
           </a:p>
@@ -1958,7 +1959,7 @@
           <a:p>
             <a:fld id="{2642D604-5A06-4222-909A-95995939C497}" type="datetimeFigureOut">
               <a:rPr lang="en-US" smtClean="0"/>
-              <a:t>3/31/2026</a:t>
+              <a:t>4/2/2026</a:t>
             </a:fld>
             <a:endParaRPr lang="en-US"/>
           </a:p>
@@ -2071,7 +2072,7 @@
           <a:p>
             <a:fld id="{2642D604-5A06-4222-909A-95995939C497}" type="datetimeFigureOut">
               <a:rPr lang="en-US" smtClean="0"/>
-              <a:t>3/31/2026</a:t>
+              <a:t>4/2/2026</a:t>
             </a:fld>
             <a:endParaRPr lang="en-US"/>
           </a:p>
@@ -2382,7 +2383,7 @@
           <a:p>
             <a:fld id="{2642D604-5A06-4222-909A-95995939C497}" type="datetimeFigureOut">
               <a:rPr lang="en-US" smtClean="0"/>
-              <a:t>3/31/2026</a:t>
+              <a:t>4/2/2026</a:t>
             </a:fld>
             <a:endParaRPr lang="en-US"/>
           </a:p>
@@ -2670,7 +2671,7 @@
           <a:p>
             <a:fld id="{2642D604-5A06-4222-909A-95995939C497}" type="datetimeFigureOut">
               <a:rPr lang="en-US" smtClean="0"/>
-              <a:t>3/31/2026</a:t>
+              <a:t>4/2/2026</a:t>
             </a:fld>
             <a:endParaRPr lang="en-US"/>
           </a:p>
@@ -2911,7 +2912,7 @@
           <a:p>
             <a:fld id="{2642D604-5A06-4222-909A-95995939C497}" type="datetimeFigureOut">
               <a:rPr lang="en-US" smtClean="0"/>
-              <a:t>3/31/2026</a:t>
+              <a:t>4/2/2026</a:t>
             </a:fld>
             <a:endParaRPr lang="en-US"/>
           </a:p>
@@ -3600,6 +3601,96 @@
     <p:extLst>
       <p:ext uri="{BB962C8B-B14F-4D97-AF65-F5344CB8AC3E}">
         <p14:creationId xmlns:p14="http://schemas.microsoft.com/office/powerpoint/2010/main" val="3068104984"/>
+      </p:ext>
+    </p:extLst>
+  </p:cSld>
+  <p:clrMapOvr>
+    <a:masterClrMapping/>
+  </p:clrMapOvr>
+</p:sld>
+</file>
+
+<file path=ppt/slides/slide4.xml><?xml version="1.0" encoding="utf-8"?>
+<p:sld xmlns:a="http://schemas.openxmlformats.org/drawingml/2006/main" xmlns:r="http://schemas.openxmlformats.org/officeDocument/2006/relationships" xmlns:p="http://schemas.openxmlformats.org/presentationml/2006/main">
+  <p:cSld>
+    <p:spTree>
+      <p:nvGrpSpPr>
+        <p:cNvPr id="1" name=""/>
+        <p:cNvGrpSpPr/>
+        <p:nvPr/>
+      </p:nvGrpSpPr>
+      <p:grpSpPr>
+        <a:xfrm>
+          <a:off x="0" y="0"/>
+          <a:ext cx="0" cy="0"/>
+          <a:chOff x="0" y="0"/>
+          <a:chExt cx="0" cy="0"/>
+        </a:xfrm>
+      </p:grpSpPr>
+      <p:sp>
+        <p:nvSpPr>
+          <p:cNvPr id="2" name="Title 1">
+            <a:extLst>
+              <a:ext uri="{FF2B5EF4-FFF2-40B4-BE49-F238E27FC236}">
+                <a16:creationId xmlns:a16="http://schemas.microsoft.com/office/drawing/2014/main" id="{ABA88813-3034-3734-425B-24F77F90265E}"/>
+              </a:ext>
+            </a:extLst>
+          </p:cNvPr>
+          <p:cNvSpPr>
+            <a:spLocks noGrp="1"/>
+          </p:cNvSpPr>
+          <p:nvPr>
+            <p:ph type="title"/>
+          </p:nvPr>
+        </p:nvSpPr>
+        <p:spPr/>
+        <p:txBody>
+          <a:bodyPr/>
+          <a:lstStyle/>
+          <a:p>
+            <a:r>
+              <a:rPr lang="en-US" dirty="0"/>
+              <a:t>RICLPM Burn-in 50 vs 20</a:t>
+            </a:r>
+          </a:p>
+        </p:txBody>
+      </p:sp>
+      <p:pic>
+        <p:nvPicPr>
+          <p:cNvPr id="5" name="Content Placeholder 4">
+            <a:extLst>
+              <a:ext uri="{FF2B5EF4-FFF2-40B4-BE49-F238E27FC236}">
+                <a16:creationId xmlns:a16="http://schemas.microsoft.com/office/drawing/2014/main" id="{D765DE8A-00CA-25B1-A10B-F66313116A49}"/>
+              </a:ext>
+            </a:extLst>
+          </p:cNvPr>
+          <p:cNvPicPr>
+            <a:picLocks noGrp="1" noChangeAspect="1"/>
+          </p:cNvPicPr>
+          <p:nvPr>
+            <p:ph idx="1"/>
+          </p:nvPr>
+        </p:nvPicPr>
+        <p:blipFill>
+          <a:blip r:embed="rId2"/>
+          <a:stretch>
+            <a:fillRect/>
+          </a:stretch>
+        </p:blipFill>
+        <p:spPr>
+          <a:xfrm>
+            <a:off x="838200" y="2125452"/>
+            <a:ext cx="5071889" cy="3137182"/>
+          </a:xfrm>
+          <a:prstGeom prst="rect">
+            <a:avLst/>
+          </a:prstGeom>
+        </p:spPr>
+      </p:pic>
+    </p:spTree>
+    <p:extLst>
+      <p:ext uri="{BB962C8B-B14F-4D97-AF65-F5344CB8AC3E}">
+        <p14:creationId xmlns:p14="http://schemas.microsoft.com/office/powerpoint/2010/main" val="3150729735"/>
       </p:ext>
     </p:extLst>
   </p:cSld>

</xml_diff>